<commit_message>
20250115 完成“Internal Truck Scheduling System 内集卡调度系统”工程搭建
</commit_message>
<xml_diff>
--- a/Bee.CTOS.系统架构图.pptx
+++ b/Bee.CTOS.系统架构图.pptx
@@ -245,7 +245,7 @@
             <a:fld id="{9AD89A4D-DCA1-4F8E-95E9-E487FD906CDF}" type="datetimeFigureOut">
               <a:rPr lang="zh-CN" altLang="en-US" smtClean="0"/>
               <a:pPr/>
-              <a:t>2025-01-10</a:t>
+              <a:t>2025-01-15</a:t>
             </a:fld>
             <a:endParaRPr lang="zh-CN" altLang="en-US"/>
           </a:p>
@@ -441,7 +441,7 @@
               <a:pPr>
                 <a:defRPr/>
               </a:pPr>
-              <a:t>2025-01-10</a:t>
+              <a:t>2025-01-15</a:t>
             </a:fld>
             <a:endParaRPr lang="zh-CN" altLang="en-US"/>
           </a:p>
@@ -830,7 +830,7 @@
             <a:fld id="{5CE71918-5BB5-48A1-B847-28BA0F6365FD}" type="datetimeFigureOut">
               <a:rPr lang="zh-CN" altLang="en-US" smtClean="0"/>
               <a:pPr/>
-              <a:t>2025-01-10</a:t>
+              <a:t>2025-01-15</a:t>
             </a:fld>
             <a:endParaRPr lang="zh-CN" altLang="en-US"/>
           </a:p>
@@ -1137,7 +1137,7 @@
             <a:fld id="{5CE71918-5BB5-48A1-B847-28BA0F6365FD}" type="datetimeFigureOut">
               <a:rPr lang="zh-CN" altLang="en-US" smtClean="0"/>
               <a:pPr/>
-              <a:t>2025-01-10</a:t>
+              <a:t>2025-01-15</a:t>
             </a:fld>
             <a:endParaRPr lang="zh-CN" altLang="en-US"/>
           </a:p>
@@ -1387,7 +1387,7 @@
             <a:fld id="{5CE71918-5BB5-48A1-B847-28BA0F6365FD}" type="datetimeFigureOut">
               <a:rPr lang="zh-CN" altLang="en-US" smtClean="0"/>
               <a:pPr/>
-              <a:t>2025-01-10</a:t>
+              <a:t>2025-01-15</a:t>
             </a:fld>
             <a:endParaRPr lang="zh-CN" altLang="en-US"/>
           </a:p>
@@ -1553,7 +1553,7 @@
             <a:fld id="{5CE71918-5BB5-48A1-B847-28BA0F6365FD}" type="datetimeFigureOut">
               <a:rPr lang="zh-CN" altLang="en-US" smtClean="0"/>
               <a:pPr/>
-              <a:t>2025-01-10</a:t>
+              <a:t>2025-01-15</a:t>
             </a:fld>
             <a:endParaRPr lang="zh-CN" altLang="en-US"/>
           </a:p>
@@ -1729,7 +1729,7 @@
             <a:fld id="{5CE71918-5BB5-48A1-B847-28BA0F6365FD}" type="datetimeFigureOut">
               <a:rPr lang="zh-CN" altLang="en-US" smtClean="0"/>
               <a:pPr/>
-              <a:t>2025-01-10</a:t>
+              <a:t>2025-01-15</a:t>
             </a:fld>
             <a:endParaRPr lang="zh-CN" altLang="en-US"/>
           </a:p>
@@ -3455,7 +3455,7 @@
             <a:fld id="{5CE71918-5BB5-48A1-B847-28BA0F6365FD}" type="datetimeFigureOut">
               <a:rPr lang="zh-CN" altLang="en-US" smtClean="0"/>
               <a:pPr/>
-              <a:t>2025-01-10</a:t>
+              <a:t>2025-01-15</a:t>
             </a:fld>
             <a:endParaRPr lang="zh-CN" altLang="en-US"/>
           </a:p>
@@ -3553,7 +3553,7 @@
               <a:pPr>
                 <a:defRPr/>
               </a:pPr>
-              <a:t>2025-01-10</a:t>
+              <a:t>2025-01-15</a:t>
             </a:fld>
             <a:endParaRPr lang="zh-CN" altLang="en-US"/>
           </a:p>
@@ -3844,7 +3844,7 @@
             <a:fld id="{5CE71918-5BB5-48A1-B847-28BA0F6365FD}" type="datetimeFigureOut">
               <a:rPr lang="zh-CN" altLang="en-US" smtClean="0"/>
               <a:pPr/>
-              <a:t>2025-01-10</a:t>
+              <a:t>2025-01-15</a:t>
             </a:fld>
             <a:endParaRPr lang="zh-CN" altLang="en-US"/>
           </a:p>
@@ -4127,7 +4127,7 @@
             <a:fld id="{5CE71918-5BB5-48A1-B847-28BA0F6365FD}" type="datetimeFigureOut">
               <a:rPr lang="zh-CN" altLang="en-US" smtClean="0"/>
               <a:pPr/>
-              <a:t>2025-01-10</a:t>
+              <a:t>2025-01-15</a:t>
             </a:fld>
             <a:endParaRPr lang="zh-CN" altLang="en-US"/>
           </a:p>
@@ -4549,7 +4549,7 @@
             <a:fld id="{5CE71918-5BB5-48A1-B847-28BA0F6365FD}" type="datetimeFigureOut">
               <a:rPr lang="zh-CN" altLang="en-US" smtClean="0"/>
               <a:pPr/>
-              <a:t>2025-01-10</a:t>
+              <a:t>2025-01-15</a:t>
             </a:fld>
             <a:endParaRPr lang="zh-CN" altLang="en-US"/>
           </a:p>
@@ -4664,7 +4664,7 @@
             <a:fld id="{5CE71918-5BB5-48A1-B847-28BA0F6365FD}" type="datetimeFigureOut">
               <a:rPr lang="zh-CN" altLang="en-US" smtClean="0"/>
               <a:pPr/>
-              <a:t>2025-01-10</a:t>
+              <a:t>2025-01-15</a:t>
             </a:fld>
             <a:endParaRPr lang="zh-CN" altLang="en-US"/>
           </a:p>
@@ -5385,7 +5385,7 @@
             <a:fld id="{5CE71918-5BB5-48A1-B847-28BA0F6365FD}" type="datetimeFigureOut">
               <a:rPr lang="zh-CN" altLang="en-US" smtClean="0"/>
               <a:pPr/>
-              <a:t>2025-01-10</a:t>
+              <a:t>2025-01-15</a:t>
             </a:fld>
             <a:endParaRPr lang="zh-CN" altLang="en-US"/>
           </a:p>
@@ -6647,7 +6647,7 @@
                 <a:latin typeface="微软雅黑" panose="020B0503020204020204" pitchFamily="34" charset="-122"/>
                 <a:ea typeface="微软雅黑" panose="020B0503020204020204" pitchFamily="34" charset="-122"/>
               </a:rPr>
-              <a:t>水平运输调度</a:t>
+              <a:t>内集卡调度</a:t>
             </a:r>
             <a:endParaRPr lang="en-US" altLang="zh-CN" sz="600" dirty="0">
               <a:solidFill>
@@ -6667,7 +6667,7 @@
                 <a:latin typeface="微软雅黑" panose="020B0503020204020204" pitchFamily="34" charset="-122"/>
                 <a:ea typeface="微软雅黑" panose="020B0503020204020204" pitchFamily="34" charset="-122"/>
               </a:rPr>
-              <a:t>Collaborative Truck Scheduling System</a:t>
+              <a:t>Internal Truck Scheduling System</a:t>
             </a:r>
             <a:endParaRPr lang="zh-CN" altLang="en-US" sz="600" dirty="0">
               <a:solidFill>

</xml_diff>